<commit_message>
Update PowerPoint for song #151 in FUBC - Українські
</commit_message>
<xml_diff>
--- a/fubc-ua/151-Тебе хвалити хочу співом (Пісні Спасенних №148).pptx
+++ b/fubc-ua/151-Тебе хвалити хочу співом (Пісні Спасенних №148).pptx
@@ -594,7 +594,7 @@
           <a:p>
             <a:r>
               <a:rPr lang="en-US" dirty="0"/>
-              <a:t>1 · 1/1</a:t>
+              <a:t>1 · 1/1 · ||:5-6:||</a:t>
             </a:r>
             <a:endParaRPr lang="en-US" dirty="0"/>
           </a:p>
@@ -682,7 +682,7 @@
           <a:p>
             <a:r>
               <a:rPr lang="en-US" dirty="0"/>
-              <a:t>2 · 1/1</a:t>
+              <a:t>2 · 1/1 · ||:5-6:|| · rows:1,1,1,1,1,2</a:t>
             </a:r>
             <a:endParaRPr lang="en-US" dirty="0"/>
           </a:p>
@@ -770,7 +770,7 @@
           <a:p>
             <a:r>
               <a:rPr lang="en-US" dirty="0"/>
-              <a:t>3 · 1/1</a:t>
+              <a:t>3 · 1/1 · ||:5-6:|| · rows:1,1,1,1,1,2</a:t>
             </a:r>
             <a:endParaRPr lang="en-US" dirty="0"/>
           </a:p>
@@ -1341,6 +1341,9 @@
           <a:lstStyle/>
           <a:p>
             <a:pPr algn="ctr" indent="0" marL="0">
+              <a:lnSpc>
+                <a:spcPts val="6200"/>
+              </a:lnSpc>
               <a:buNone/>
             </a:pPr>
             <a:r>
@@ -1358,6 +1361,9 @@
           </a:p>
           <a:p>
             <a:pPr algn="ctr" indent="0" marL="0">
+              <a:lnSpc>
+                <a:spcPts val="6200"/>
+              </a:lnSpc>
               <a:buNone/>
             </a:pPr>
             <a:r>
@@ -1375,6 +1381,9 @@
           </a:p>
           <a:p>
             <a:pPr algn="ctr" indent="0" marL="0">
+              <a:lnSpc>
+                <a:spcPts val="6200"/>
+              </a:lnSpc>
               <a:buNone/>
             </a:pPr>
             <a:r>
@@ -1392,6 +1401,9 @@
           </a:p>
           <a:p>
             <a:pPr algn="ctr" indent="0" marL="0">
+              <a:lnSpc>
+                <a:spcPts val="6200"/>
+              </a:lnSpc>
               <a:buNone/>
             </a:pPr>
             <a:r>
@@ -1409,6 +1421,9 @@
           </a:p>
           <a:p>
             <a:pPr algn="ctr" indent="0" marL="0">
+              <a:lnSpc>
+                <a:spcPts val="6200"/>
+              </a:lnSpc>
               <a:buNone/>
             </a:pPr>
             <a:r>
@@ -1420,12 +1435,15 @@
                 <a:ea typeface="Arial" pitchFamily="34" charset="-122"/>
                 <a:cs typeface="Arial" pitchFamily="34" charset="-120"/>
               </a:rPr>
-              <a:t>||: Ніколи я не перестану</a:t>
+              <a:t>Ніколи я не перестану</a:t>
             </a:r>
             <a:endParaRPr lang="en-US" sz="5200" dirty="0"/>
           </a:p>
           <a:p>
             <a:pPr algn="ctr" indent="0" marL="0">
+              <a:lnSpc>
+                <a:spcPts val="6200"/>
+              </a:lnSpc>
               <a:buNone/>
             </a:pPr>
             <a:r>
@@ -1437,9 +1455,94 @@
                 <a:ea typeface="Arial" pitchFamily="34" charset="-122"/>
                 <a:cs typeface="Arial" pitchFamily="34" charset="-120"/>
               </a:rPr>
-              <a:t>співати славу і осанну! :||</a:t>
+              <a:t>співати славу і осанну!</a:t>
             </a:r>
             <a:endParaRPr lang="en-US" sz="5200" dirty="0"/>
+          </a:p>
+        </p:txBody>
+      </p:sp>
+      <p:sp>
+        <p:nvSpPr>
+          <p:cNvPr id="3" name="Shape 1"/>
+          <p:cNvSpPr/>
+          <p:nvPr/>
+        </p:nvSpPr>
+        <p:spPr>
+          <a:xfrm>
+            <a:off x="2049475" y="4340352"/>
+            <a:ext cx="0" cy="1386840"/>
+          </a:xfrm>
+          <a:prstGeom prst="line">
+            <a:avLst/>
+          </a:prstGeom>
+          <a:noFill/>
+          <a:ln w="25400">
+            <a:solidFill>
+              <a:srgbClr val="8A8A8A"/>
+            </a:solidFill>
+            <a:prstDash val="solid"/>
+          </a:ln>
+        </p:spPr>
+      </p:sp>
+      <p:sp>
+        <p:nvSpPr>
+          <p:cNvPr id="4" name="Shape 2"/>
+          <p:cNvSpPr/>
+          <p:nvPr/>
+        </p:nvSpPr>
+        <p:spPr>
+          <a:xfrm>
+            <a:off x="10148621" y="4340352"/>
+            <a:ext cx="0" cy="1386840"/>
+          </a:xfrm>
+          <a:prstGeom prst="line">
+            <a:avLst/>
+          </a:prstGeom>
+          <a:noFill/>
+          <a:ln w="25400">
+            <a:solidFill>
+              <a:srgbClr val="8A8A8A"/>
+            </a:solidFill>
+            <a:prstDash val="solid"/>
+          </a:ln>
+        </p:spPr>
+      </p:sp>
+      <p:sp>
+        <p:nvSpPr>
+          <p:cNvPr id="5" name="Text 3"/>
+          <p:cNvSpPr txBox="1"/>
+          <p:nvPr/>
+        </p:nvSpPr>
+        <p:spPr>
+          <a:xfrm>
+            <a:off x="10247681" y="4713732"/>
+            <a:ext cx="1097280" cy="640080"/>
+          </a:xfrm>
+          <a:prstGeom prst="rect">
+            <a:avLst/>
+          </a:prstGeom>
+          <a:noFill/>
+          <a:ln/>
+        </p:spPr>
+        <p:txBody>
+          <a:bodyPr wrap="square" lIns="0" tIns="0" rIns="0" bIns="0" rtlCol="0" anchor="ctr"/>
+          <a:lstStyle/>
+          <a:p>
+            <a:pPr algn="l" indent="0" marL="0">
+              <a:buNone/>
+            </a:pPr>
+            <a:r>
+              <a:rPr lang="en-US" sz="3600" b="1" dirty="0">
+                <a:solidFill>
+                  <a:srgbClr val="BBBBBB"/>
+                </a:solidFill>
+                <a:latin typeface="Arial" pitchFamily="34" charset="0"/>
+                <a:ea typeface="Arial" pitchFamily="34" charset="-122"/>
+                <a:cs typeface="Arial" pitchFamily="34" charset="-120"/>
+              </a:rPr>
+              <a:t>×2</a:t>
+            </a:r>
+            <a:endParaRPr lang="en-US" sz="3600" dirty="0"/>
           </a:p>
         </p:txBody>
       </p:sp>
@@ -1497,6 +1600,9 @@
           <a:lstStyle/>
           <a:p>
             <a:pPr algn="ctr" indent="0" marL="0">
+              <a:lnSpc>
+                <a:spcPts val="6200"/>
+              </a:lnSpc>
               <a:buNone/>
             </a:pPr>
             <a:r>
@@ -1514,6 +1620,9 @@
           </a:p>
           <a:p>
             <a:pPr algn="ctr" indent="0" marL="0">
+              <a:lnSpc>
+                <a:spcPts val="6200"/>
+              </a:lnSpc>
               <a:buNone/>
             </a:pPr>
             <a:r>
@@ -1531,6 +1640,9 @@
           </a:p>
           <a:p>
             <a:pPr algn="ctr" indent="0" marL="0">
+              <a:lnSpc>
+                <a:spcPts val="6200"/>
+              </a:lnSpc>
               <a:buNone/>
             </a:pPr>
             <a:r>
@@ -1548,6 +1660,9 @@
           </a:p>
           <a:p>
             <a:pPr algn="ctr" indent="0" marL="0">
+              <a:lnSpc>
+                <a:spcPts val="6200"/>
+              </a:lnSpc>
               <a:buNone/>
             </a:pPr>
             <a:r>
@@ -1565,6 +1680,9 @@
           </a:p>
           <a:p>
             <a:pPr algn="ctr" indent="0" marL="0">
+              <a:lnSpc>
+                <a:spcPts val="6200"/>
+              </a:lnSpc>
               <a:buNone/>
             </a:pPr>
             <a:r>
@@ -1576,12 +1694,15 @@
                 <a:ea typeface="Arial" pitchFamily="34" charset="-122"/>
                 <a:cs typeface="Arial" pitchFamily="34" charset="-120"/>
               </a:rPr>
-              <a:t>||: Щасливий я, коли співаю,</a:t>
+              <a:t>Щасливий я, коли співаю,</a:t>
             </a:r>
             <a:endParaRPr lang="en-US" sz="5200" dirty="0"/>
           </a:p>
           <a:p>
             <a:pPr algn="ctr" indent="0" marL="0">
+              <a:lnSpc>
+                <a:spcPts val="6200"/>
+              </a:lnSpc>
               <a:buNone/>
             </a:pPr>
             <a:r>
@@ -1593,9 +1714,114 @@
                 <a:ea typeface="Arial" pitchFamily="34" charset="-122"/>
                 <a:cs typeface="Arial" pitchFamily="34" charset="-120"/>
               </a:rPr>
-              <a:t>Тебе в смиренні прославляю. :||</a:t>
+              <a:t>Тебе в смиренні</a:t>
             </a:r>
             <a:endParaRPr lang="en-US" sz="5200" dirty="0"/>
+          </a:p>
+          <a:p>
+            <a:pPr algn="ctr" indent="0" marL="0">
+              <a:lnSpc>
+                <a:spcPts val="6200"/>
+              </a:lnSpc>
+              <a:buNone/>
+            </a:pPr>
+            <a:r>
+              <a:rPr lang="en-US" sz="5200" b="1" dirty="0">
+                <a:solidFill>
+                  <a:srgbClr val="FFFFFF"/>
+                </a:solidFill>
+                <a:latin typeface="Arial" pitchFamily="34" charset="0"/>
+                <a:ea typeface="Arial" pitchFamily="34" charset="-122"/>
+                <a:cs typeface="Arial" pitchFamily="34" charset="-120"/>
+              </a:rPr>
+              <a:t>прославляю.</a:t>
+            </a:r>
+            <a:endParaRPr lang="en-US" sz="5200" dirty="0"/>
+          </a:p>
+        </p:txBody>
+      </p:sp>
+      <p:sp>
+        <p:nvSpPr>
+          <p:cNvPr id="3" name="Shape 1"/>
+          <p:cNvSpPr/>
+          <p:nvPr/>
+        </p:nvSpPr>
+        <p:spPr>
+          <a:xfrm>
+            <a:off x="1567713" y="3944112"/>
+            <a:ext cx="0" cy="2179320"/>
+          </a:xfrm>
+          <a:prstGeom prst="line">
+            <a:avLst/>
+          </a:prstGeom>
+          <a:noFill/>
+          <a:ln w="25400">
+            <a:solidFill>
+              <a:srgbClr val="8A8A8A"/>
+            </a:solidFill>
+            <a:prstDash val="solid"/>
+          </a:ln>
+        </p:spPr>
+      </p:sp>
+      <p:sp>
+        <p:nvSpPr>
+          <p:cNvPr id="4" name="Shape 2"/>
+          <p:cNvSpPr/>
+          <p:nvPr/>
+        </p:nvSpPr>
+        <p:spPr>
+          <a:xfrm>
+            <a:off x="10630383" y="3944112"/>
+            <a:ext cx="0" cy="2179320"/>
+          </a:xfrm>
+          <a:prstGeom prst="line">
+            <a:avLst/>
+          </a:prstGeom>
+          <a:noFill/>
+          <a:ln w="25400">
+            <a:solidFill>
+              <a:srgbClr val="8A8A8A"/>
+            </a:solidFill>
+            <a:prstDash val="solid"/>
+          </a:ln>
+        </p:spPr>
+      </p:sp>
+      <p:sp>
+        <p:nvSpPr>
+          <p:cNvPr id="5" name="Text 3"/>
+          <p:cNvSpPr txBox="1"/>
+          <p:nvPr/>
+        </p:nvSpPr>
+        <p:spPr>
+          <a:xfrm>
+            <a:off x="10729443" y="4713732"/>
+            <a:ext cx="1097280" cy="640080"/>
+          </a:xfrm>
+          <a:prstGeom prst="rect">
+            <a:avLst/>
+          </a:prstGeom>
+          <a:noFill/>
+          <a:ln/>
+        </p:spPr>
+        <p:txBody>
+          <a:bodyPr wrap="square" lIns="0" tIns="0" rIns="0" bIns="0" rtlCol="0" anchor="ctr"/>
+          <a:lstStyle/>
+          <a:p>
+            <a:pPr algn="l" indent="0" marL="0">
+              <a:buNone/>
+            </a:pPr>
+            <a:r>
+              <a:rPr lang="en-US" sz="3600" b="1" dirty="0">
+                <a:solidFill>
+                  <a:srgbClr val="BBBBBB"/>
+                </a:solidFill>
+                <a:latin typeface="Arial" pitchFamily="34" charset="0"/>
+                <a:ea typeface="Arial" pitchFamily="34" charset="-122"/>
+                <a:cs typeface="Arial" pitchFamily="34" charset="-120"/>
+              </a:rPr>
+              <a:t>×2</a:t>
+            </a:r>
+            <a:endParaRPr lang="en-US" sz="3600" dirty="0"/>
           </a:p>
         </p:txBody>
       </p:sp>
@@ -1653,10 +1879,13 @@
           <a:lstStyle/>
           <a:p>
             <a:pPr algn="ctr" indent="0" marL="0">
-              <a:buNone/>
-            </a:pPr>
-            <a:r>
-              <a:rPr lang="en-US" sz="5200" b="1" dirty="0">
+              <a:lnSpc>
+                <a:spcPts val="6000"/>
+              </a:lnSpc>
+              <a:buNone/>
+            </a:pPr>
+            <a:r>
+              <a:rPr lang="en-US" sz="5000" b="1" dirty="0">
                 <a:solidFill>
                   <a:srgbClr val="FFFFFF"/>
                 </a:solidFill>
@@ -1666,14 +1895,17 @@
               </a:rPr>
               <a:t>Тебе святити я бажаю</a:t>
             </a:r>
-            <a:endParaRPr lang="en-US" sz="5200" dirty="0"/>
+            <a:endParaRPr lang="en-US" sz="5000" dirty="0"/>
           </a:p>
           <a:p>
             <a:pPr algn="ctr" indent="0" marL="0">
-              <a:buNone/>
-            </a:pPr>
-            <a:r>
-              <a:rPr lang="en-US" sz="5200" b="1" dirty="0">
+              <a:lnSpc>
+                <a:spcPts val="6000"/>
+              </a:lnSpc>
+              <a:buNone/>
+            </a:pPr>
+            <a:r>
+              <a:rPr lang="en-US" sz="5000" b="1" dirty="0">
                 <a:solidFill>
                   <a:srgbClr val="FFFFFF"/>
                 </a:solidFill>
@@ -1683,14 +1915,17 @@
               </a:rPr>
               <a:t>завжди із вдячністю в душі.</a:t>
             </a:r>
-            <a:endParaRPr lang="en-US" sz="5200" dirty="0"/>
+            <a:endParaRPr lang="en-US" sz="5000" dirty="0"/>
           </a:p>
           <a:p>
             <a:pPr algn="ctr" indent="0" marL="0">
-              <a:buNone/>
-            </a:pPr>
-            <a:r>
-              <a:rPr lang="en-US" sz="5200" b="1" dirty="0">
+              <a:lnSpc>
+                <a:spcPts val="6000"/>
+              </a:lnSpc>
+              <a:buNone/>
+            </a:pPr>
+            <a:r>
+              <a:rPr lang="en-US" sz="5000" b="1" dirty="0">
                 <a:solidFill>
                   <a:srgbClr val="FFFFFF"/>
                 </a:solidFill>
@@ -1700,14 +1935,17 @@
               </a:rPr>
               <a:t>Дай сил дійти до небокраю,</a:t>
             </a:r>
-            <a:endParaRPr lang="en-US" sz="5200" dirty="0"/>
+            <a:endParaRPr lang="en-US" sz="5000" dirty="0"/>
           </a:p>
           <a:p>
             <a:pPr algn="ctr" indent="0" marL="0">
-              <a:buNone/>
-            </a:pPr>
-            <a:r>
-              <a:rPr lang="en-US" sz="5200" b="1" dirty="0">
+              <a:lnSpc>
+                <a:spcPts val="6000"/>
+              </a:lnSpc>
+              <a:buNone/>
+            </a:pPr>
+            <a:r>
+              <a:rPr lang="en-US" sz="5000" b="1" dirty="0">
                 <a:solidFill>
                   <a:srgbClr val="FFFFFF"/>
                 </a:solidFill>
@@ -1717,14 +1955,17 @@
               </a:rPr>
               <a:t>де Ти царюєш у красі.</a:t>
             </a:r>
-            <a:endParaRPr lang="en-US" sz="5200" dirty="0"/>
+            <a:endParaRPr lang="en-US" sz="5000" dirty="0"/>
           </a:p>
           <a:p>
             <a:pPr algn="ctr" indent="0" marL="0">
-              <a:buNone/>
-            </a:pPr>
-            <a:r>
-              <a:rPr lang="en-US" sz="5200" b="1" dirty="0">
+              <a:lnSpc>
+                <a:spcPts val="6000"/>
+              </a:lnSpc>
+              <a:buNone/>
+            </a:pPr>
+            <a:r>
+              <a:rPr lang="en-US" sz="5000" b="1" dirty="0">
                 <a:solidFill>
                   <a:srgbClr val="FFFFFF"/>
                 </a:solidFill>
@@ -1732,16 +1973,19 @@
                 <a:ea typeface="Arial" pitchFamily="34" charset="-122"/>
                 <a:cs typeface="Arial" pitchFamily="34" charset="-120"/>
               </a:rPr>
-              <a:t>||: Тобі в просторах безконечних</a:t>
-            </a:r>
-            <a:endParaRPr lang="en-US" sz="5200" dirty="0"/>
+              <a:t>Тобі в просторах безконечних</a:t>
+            </a:r>
+            <a:endParaRPr lang="en-US" sz="5000" dirty="0"/>
           </a:p>
           <a:p>
             <a:pPr algn="ctr" indent="0" marL="0">
-              <a:buNone/>
-            </a:pPr>
-            <a:r>
-              <a:rPr lang="en-US" sz="5200" b="1" dirty="0">
+              <a:lnSpc>
+                <a:spcPts val="6000"/>
+              </a:lnSpc>
+              <a:buNone/>
+            </a:pPr>
+            <a:r>
+              <a:rPr lang="en-US" sz="5000" b="1" dirty="0">
                 <a:solidFill>
                   <a:srgbClr val="FFFFFF"/>
                 </a:solidFill>
@@ -1749,15 +1993,120 @@
                 <a:ea typeface="Arial" pitchFamily="34" charset="-122"/>
                 <a:cs typeface="Arial" pitchFamily="34" charset="-120"/>
               </a:rPr>
-              <a:t>поллється спів хвали сердечний. :||</a:t>
-            </a:r>
-            <a:endParaRPr lang="en-US" sz="5200" dirty="0"/>
+              <a:t>поллється спів</a:t>
+            </a:r>
+            <a:endParaRPr lang="en-US" sz="5000" dirty="0"/>
+          </a:p>
+          <a:p>
+            <a:pPr algn="ctr" indent="0" marL="0">
+              <a:lnSpc>
+                <a:spcPts val="6000"/>
+              </a:lnSpc>
+              <a:buNone/>
+            </a:pPr>
+            <a:r>
+              <a:rPr lang="en-US" sz="5000" b="1" dirty="0">
+                <a:solidFill>
+                  <a:srgbClr val="FFFFFF"/>
+                </a:solidFill>
+                <a:latin typeface="Arial" pitchFamily="34" charset="0"/>
+                <a:ea typeface="Arial" pitchFamily="34" charset="-122"/>
+                <a:cs typeface="Arial" pitchFamily="34" charset="-120"/>
+              </a:rPr>
+              <a:t>хвали сердечний.</a:t>
+            </a:r>
+            <a:endParaRPr lang="en-US" sz="5000" dirty="0"/>
           </a:p>
         </p:txBody>
       </p:sp>
       <p:sp>
         <p:nvSpPr>
-          <p:cNvPr id="3" name="Text 1"/>
+          <p:cNvPr id="3" name="Shape 1"/>
+          <p:cNvSpPr/>
+          <p:nvPr/>
+        </p:nvSpPr>
+        <p:spPr>
+          <a:xfrm>
+            <a:off x="1091755" y="3924300"/>
+            <a:ext cx="0" cy="2095500"/>
+          </a:xfrm>
+          <a:prstGeom prst="line">
+            <a:avLst/>
+          </a:prstGeom>
+          <a:noFill/>
+          <a:ln w="24423">
+            <a:solidFill>
+              <a:srgbClr val="8A8A8A"/>
+            </a:solidFill>
+            <a:prstDash val="solid"/>
+          </a:ln>
+        </p:spPr>
+      </p:sp>
+      <p:sp>
+        <p:nvSpPr>
+          <p:cNvPr id="4" name="Shape 2"/>
+          <p:cNvSpPr/>
+          <p:nvPr/>
+        </p:nvSpPr>
+        <p:spPr>
+          <a:xfrm>
+            <a:off x="11106341" y="3924300"/>
+            <a:ext cx="0" cy="2095500"/>
+          </a:xfrm>
+          <a:prstGeom prst="line">
+            <a:avLst/>
+          </a:prstGeom>
+          <a:noFill/>
+          <a:ln w="24423">
+            <a:solidFill>
+              <a:srgbClr val="8A8A8A"/>
+            </a:solidFill>
+            <a:prstDash val="solid"/>
+          </a:ln>
+        </p:spPr>
+      </p:sp>
+      <p:sp>
+        <p:nvSpPr>
+          <p:cNvPr id="5" name="Text 3"/>
+          <p:cNvSpPr txBox="1"/>
+          <p:nvPr/>
+        </p:nvSpPr>
+        <p:spPr>
+          <a:xfrm>
+            <a:off x="11201591" y="4660900"/>
+            <a:ext cx="1066800" cy="622300"/>
+          </a:xfrm>
+          <a:prstGeom prst="rect">
+            <a:avLst/>
+          </a:prstGeom>
+          <a:noFill/>
+          <a:ln/>
+        </p:spPr>
+        <p:txBody>
+          <a:bodyPr wrap="square" lIns="0" tIns="0" rIns="0" bIns="0" rtlCol="0" anchor="ctr"/>
+          <a:lstStyle/>
+          <a:p>
+            <a:pPr algn="l" indent="0" marL="0">
+              <a:buNone/>
+            </a:pPr>
+            <a:r>
+              <a:rPr lang="en-US" sz="3500" b="1" dirty="0">
+                <a:solidFill>
+                  <a:srgbClr val="BBBBBB"/>
+                </a:solidFill>
+                <a:latin typeface="Arial" pitchFamily="34" charset="0"/>
+                <a:ea typeface="Arial" pitchFamily="34" charset="-122"/>
+                <a:cs typeface="Arial" pitchFamily="34" charset="-120"/>
+              </a:rPr>
+              <a:t>×2</a:t>
+            </a:r>
+            <a:endParaRPr lang="en-US" sz="3500" dirty="0"/>
+          </a:p>
+        </p:txBody>
+      </p:sp>
+      <p:sp>
+        <p:nvSpPr>
+          <p:cNvPr id="6" name="Text 4"/>
           <p:cNvSpPr txBox="1"/>
           <p:nvPr/>
         </p:nvSpPr>

</xml_diff>